<commit_message>
Split into 2 slides, larger text, add Brand Communications topic
https://claude.ai/code/session_01WrWvRy3cmy4KyPGfUNpCAm
</commit_message>
<xml_diff>
--- a/masterarbeitsthemen.pptx
+++ b/masterarbeitsthemen.pptx
@@ -6,6 +6,7 @@
   </p:sldMasterIdLst>
   <p:sldIdLst>
     <p:sldId id="256" r:id="rId7"/>
+    <p:sldId id="257" r:id="rId8"/>
   </p:sldIdLst>
   <p:sldSz cx="12188952" cy="6858000" type="screen4x3"/>
   <p:notesSz cx="6858000" cy="9144000"/>
@@ -3097,7 +3098,7 @@
         <p:spPr>
           <a:xfrm>
             <a:off x="0" y="0"/>
-            <a:ext cx="12188952" cy="1463040"/>
+            <a:ext cx="12188952" cy="1417320"/>
           </a:xfrm>
           <a:prstGeom prst="rect">
             <a:avLst/>
@@ -3139,8 +3140,8 @@
         </p:nvSpPr>
         <p:spPr>
           <a:xfrm>
-            <a:off x="457200" y="164592"/>
-            <a:ext cx="11731752" cy="411480"/>
+            <a:off x="457200" y="146304"/>
+            <a:ext cx="11274552" cy="475488"/>
           </a:xfrm>
           <a:prstGeom prst="rect">
             <a:avLst/>
@@ -3155,7 +3156,7 @@
           <a:p>
             <a:pPr algn="l"/>
             <a:r>
-              <a:rPr sz="2800" b="1">
+              <a:rPr sz="3000" b="1">
                 <a:solidFill>
                   <a:srgbClr val="FFFFFF"/>
                 </a:solidFill>
@@ -3174,8 +3175,8 @@
         </p:nvSpPr>
         <p:spPr>
           <a:xfrm>
-            <a:off x="457200" y="566928"/>
-            <a:ext cx="11731752" cy="274320"/>
+            <a:off x="457200" y="603504"/>
+            <a:ext cx="11274552" cy="274320"/>
           </a:xfrm>
           <a:prstGeom prst="rect">
             <a:avLst/>
@@ -3190,7 +3191,7 @@
           <a:p>
             <a:pPr algn="l"/>
             <a:r>
-              <a:rPr sz="1100" b="0">
+              <a:rPr sz="1200" b="0">
                 <a:solidFill>
                   <a:srgbClr val="B4B4C8"/>
                 </a:solidFill>
@@ -3209,8 +3210,8 @@
         </p:nvSpPr>
         <p:spPr>
           <a:xfrm>
-            <a:off x="457200" y="914400"/>
-            <a:ext cx="3840480" cy="347472"/>
+            <a:off x="457200" y="950976"/>
+            <a:ext cx="4023360" cy="329184"/>
           </a:xfrm>
           <a:prstGeom prst="rect">
             <a:avLst/>
@@ -3254,8 +3255,8 @@
         </p:nvSpPr>
         <p:spPr>
           <a:xfrm>
-            <a:off x="594360" y="960120"/>
-            <a:ext cx="3840480" cy="347472"/>
+            <a:off x="594360" y="1005840"/>
+            <a:ext cx="3840480" cy="256032"/>
           </a:xfrm>
           <a:prstGeom prst="rect">
             <a:avLst/>
@@ -3283,14 +3284,49 @@
       </p:sp>
       <p:sp>
         <p:nvSpPr>
-          <p:cNvPr id="7" name="Rectangle 6"/>
+          <p:cNvPr id="7" name="TextBox 6"/>
+          <p:cNvSpPr txBox="1"/>
+          <p:nvPr/>
+        </p:nvSpPr>
+        <p:spPr>
+          <a:xfrm>
+            <a:off x="11091672" y="91440"/>
+            <a:ext cx="914400" cy="274320"/>
+          </a:xfrm>
+          <a:prstGeom prst="rect">
+            <a:avLst/>
+          </a:prstGeom>
+          <a:noFill/>
+        </p:spPr>
+        <p:txBody>
+          <a:bodyPr wrap="square">
+            <a:spAutoFit/>
+          </a:bodyPr>
+          <a:lstStyle/>
+          <a:p>
+            <a:pPr algn="r"/>
+            <a:r>
+              <a:rPr sz="1000" b="0">
+                <a:solidFill>
+                  <a:srgbClr val="8C8CAA"/>
+                </a:solidFill>
+                <a:latin typeface="Calibri"/>
+              </a:rPr>
+              <a:t>1 / 2</a:t>
+            </a:r>
+          </a:p>
+        </p:txBody>
+      </p:sp>
+      <p:sp>
+        <p:nvSpPr>
+          <p:cNvPr id="8" name="Rectangle 7"/>
           <p:cNvSpPr/>
           <p:nvPr/>
         </p:nvSpPr>
         <p:spPr>
           <a:xfrm>
-            <a:off x="457200" y="1627632"/>
-            <a:ext cx="11274552" cy="804672"/>
+            <a:off x="457200" y="1527048"/>
+            <a:ext cx="11274552" cy="1615440"/>
           </a:xfrm>
           <a:prstGeom prst="rect">
             <a:avLst/>
@@ -3328,14 +3364,14 @@
       </p:sp>
       <p:sp>
         <p:nvSpPr>
-          <p:cNvPr id="8" name="TextBox 7"/>
+          <p:cNvPr id="9" name="TextBox 8"/>
           <p:cNvSpPr txBox="1"/>
           <p:nvPr/>
         </p:nvSpPr>
         <p:spPr>
           <a:xfrm>
-            <a:off x="566928" y="1737360"/>
-            <a:ext cx="411480" cy="804672"/>
+            <a:off x="548640" y="1618488"/>
+            <a:ext cx="457200" cy="1615440"/>
           </a:xfrm>
           <a:prstGeom prst="rect">
             <a:avLst/>
@@ -3350,9 +3386,9 @@
           <a:p>
             <a:pPr algn="l"/>
             <a:r>
-              <a:rPr sz="2200" b="1">
-                <a:solidFill>
-                  <a:srgbClr val="DCDCDC"/>
+              <a:rPr sz="2600" b="1">
+                <a:solidFill>
+                  <a:srgbClr val="D7D7D7"/>
                 </a:solidFill>
                 <a:latin typeface="Calibri"/>
               </a:rPr>
@@ -3363,14 +3399,14 @@
       </p:sp>
       <p:sp>
         <p:nvSpPr>
-          <p:cNvPr id="9" name="Rectangle 8"/>
+          <p:cNvPr id="10" name="Rectangle 9"/>
           <p:cNvSpPr/>
           <p:nvPr/>
         </p:nvSpPr>
         <p:spPr>
           <a:xfrm>
-            <a:off x="1005840" y="1719072"/>
-            <a:ext cx="1554480" cy="201168"/>
+            <a:off x="1024128" y="1618488"/>
+            <a:ext cx="1920240" cy="237744"/>
           </a:xfrm>
           <a:prstGeom prst="rect">
             <a:avLst/>
@@ -3406,14 +3442,14 @@
       </p:sp>
       <p:sp>
         <p:nvSpPr>
-          <p:cNvPr id="10" name="TextBox 9"/>
+          <p:cNvPr id="11" name="TextBox 10"/>
           <p:cNvSpPr txBox="1"/>
           <p:nvPr/>
         </p:nvSpPr>
         <p:spPr>
           <a:xfrm>
-            <a:off x="1060704" y="1719072"/>
-            <a:ext cx="1554480" cy="201168"/>
+            <a:off x="1115568" y="1655064"/>
+            <a:ext cx="1920240" cy="237744"/>
           </a:xfrm>
           <a:prstGeom prst="rect">
             <a:avLst/>
@@ -3428,7 +3464,7 @@
           <a:p>
             <a:pPr algn="l"/>
             <a:r>
-              <a:rPr sz="700" b="1">
+              <a:rPr sz="800" b="1">
                 <a:solidFill>
                   <a:srgbClr val="A06400"/>
                 </a:solidFill>
@@ -3441,14 +3477,14 @@
       </p:sp>
       <p:sp>
         <p:nvSpPr>
-          <p:cNvPr id="11" name="TextBox 10"/>
+          <p:cNvPr id="12" name="TextBox 11"/>
           <p:cNvSpPr txBox="1"/>
           <p:nvPr/>
         </p:nvSpPr>
         <p:spPr>
           <a:xfrm>
-            <a:off x="1005840" y="1929384"/>
-            <a:ext cx="10588752" cy="256032"/>
+            <a:off x="1024128" y="1874520"/>
+            <a:ext cx="10561320" cy="329184"/>
           </a:xfrm>
           <a:prstGeom prst="rect">
             <a:avLst/>
@@ -3463,7 +3499,7 @@
           <a:p>
             <a:pPr algn="l"/>
             <a:r>
-              <a:rPr sz="1100" b="1">
+              <a:rPr sz="1300" b="1">
                 <a:solidFill>
                   <a:srgbClr val="1A1A2E"/>
                 </a:solidFill>
@@ -3476,14 +3512,14 @@
       </p:sp>
       <p:sp>
         <p:nvSpPr>
-          <p:cNvPr id="12" name="TextBox 11"/>
+          <p:cNvPr id="13" name="TextBox 12"/>
           <p:cNvSpPr txBox="1"/>
           <p:nvPr/>
         </p:nvSpPr>
         <p:spPr>
           <a:xfrm>
-            <a:off x="1005840" y="2157984"/>
-            <a:ext cx="10588752" cy="274320"/>
+            <a:off x="1024128" y="2185416"/>
+            <a:ext cx="10561320" cy="902208"/>
           </a:xfrm>
           <a:prstGeom prst="rect">
             <a:avLst/>
@@ -3498,7 +3534,7 @@
           <a:p>
             <a:pPr algn="l"/>
             <a:r>
-              <a:rPr sz="800" b="0">
+              <a:rPr sz="1000" b="0">
                 <a:solidFill>
                   <a:srgbClr val="5A6A80"/>
                 </a:solidFill>
@@ -3511,14 +3547,14 @@
       </p:sp>
       <p:sp>
         <p:nvSpPr>
-          <p:cNvPr id="13" name="Rectangle 12"/>
+          <p:cNvPr id="14" name="Rectangle 13"/>
           <p:cNvSpPr/>
           <p:nvPr/>
         </p:nvSpPr>
         <p:spPr>
           <a:xfrm>
-            <a:off x="457200" y="2496312"/>
-            <a:ext cx="11274552" cy="804672"/>
+            <a:off x="457200" y="3233928"/>
+            <a:ext cx="11274552" cy="1615440"/>
           </a:xfrm>
           <a:prstGeom prst="rect">
             <a:avLst/>
@@ -3556,14 +3592,14 @@
       </p:sp>
       <p:sp>
         <p:nvSpPr>
-          <p:cNvPr id="14" name="TextBox 13"/>
+          <p:cNvPr id="15" name="TextBox 14"/>
           <p:cNvSpPr txBox="1"/>
           <p:nvPr/>
         </p:nvSpPr>
         <p:spPr>
           <a:xfrm>
-            <a:off x="566928" y="2606040"/>
-            <a:ext cx="411480" cy="804672"/>
+            <a:off x="548640" y="3325368"/>
+            <a:ext cx="457200" cy="1615440"/>
           </a:xfrm>
           <a:prstGeom prst="rect">
             <a:avLst/>
@@ -3578,9 +3614,9 @@
           <a:p>
             <a:pPr algn="l"/>
             <a:r>
-              <a:rPr sz="2200" b="1">
-                <a:solidFill>
-                  <a:srgbClr val="DCDCDC"/>
+              <a:rPr sz="2600" b="1">
+                <a:solidFill>
+                  <a:srgbClr val="D7D7D7"/>
                 </a:solidFill>
                 <a:latin typeface="Calibri"/>
               </a:rPr>
@@ -3591,14 +3627,14 @@
       </p:sp>
       <p:sp>
         <p:nvSpPr>
-          <p:cNvPr id="15" name="Rectangle 14"/>
+          <p:cNvPr id="16" name="Rectangle 15"/>
           <p:cNvSpPr/>
           <p:nvPr/>
         </p:nvSpPr>
         <p:spPr>
           <a:xfrm>
-            <a:off x="1005840" y="2587752"/>
-            <a:ext cx="1554480" cy="201168"/>
+            <a:off x="1024128" y="3325368"/>
+            <a:ext cx="1920240" cy="237744"/>
           </a:xfrm>
           <a:prstGeom prst="rect">
             <a:avLst/>
@@ -3634,14 +3670,14 @@
       </p:sp>
       <p:sp>
         <p:nvSpPr>
-          <p:cNvPr id="16" name="TextBox 15"/>
+          <p:cNvPr id="17" name="TextBox 16"/>
           <p:cNvSpPr txBox="1"/>
           <p:nvPr/>
         </p:nvSpPr>
         <p:spPr>
           <a:xfrm>
-            <a:off x="1060704" y="2587752"/>
-            <a:ext cx="1554480" cy="201168"/>
+            <a:off x="1115568" y="3361944"/>
+            <a:ext cx="1920240" cy="237744"/>
           </a:xfrm>
           <a:prstGeom prst="rect">
             <a:avLst/>
@@ -3656,7 +3692,7 @@
           <a:p>
             <a:pPr algn="l"/>
             <a:r>
-              <a:rPr sz="700" b="1">
+              <a:rPr sz="800" b="1">
                 <a:solidFill>
                   <a:srgbClr val="A06400"/>
                 </a:solidFill>
@@ -3669,14 +3705,14 @@
       </p:sp>
       <p:sp>
         <p:nvSpPr>
-          <p:cNvPr id="17" name="TextBox 16"/>
+          <p:cNvPr id="18" name="TextBox 17"/>
           <p:cNvSpPr txBox="1"/>
           <p:nvPr/>
         </p:nvSpPr>
         <p:spPr>
           <a:xfrm>
-            <a:off x="1005840" y="2798064"/>
-            <a:ext cx="10588752" cy="256032"/>
+            <a:off x="1024128" y="3581400"/>
+            <a:ext cx="10561320" cy="329184"/>
           </a:xfrm>
           <a:prstGeom prst="rect">
             <a:avLst/>
@@ -3691,7 +3727,7 @@
           <a:p>
             <a:pPr algn="l"/>
             <a:r>
-              <a:rPr sz="1100" b="1">
+              <a:rPr sz="1300" b="1">
                 <a:solidFill>
                   <a:srgbClr val="1A1A2E"/>
                 </a:solidFill>
@@ -3704,14 +3740,14 @@
       </p:sp>
       <p:sp>
         <p:nvSpPr>
-          <p:cNvPr id="18" name="TextBox 17"/>
+          <p:cNvPr id="19" name="TextBox 18"/>
           <p:cNvSpPr txBox="1"/>
           <p:nvPr/>
         </p:nvSpPr>
         <p:spPr>
           <a:xfrm>
-            <a:off x="1005840" y="3026664"/>
-            <a:ext cx="10588752" cy="274320"/>
+            <a:off x="1024128" y="3892296"/>
+            <a:ext cx="10561320" cy="902208"/>
           </a:xfrm>
           <a:prstGeom prst="rect">
             <a:avLst/>
@@ -3726,7 +3762,7 @@
           <a:p>
             <a:pPr algn="l"/>
             <a:r>
-              <a:rPr sz="800" b="0">
+              <a:rPr sz="1000" b="0">
                 <a:solidFill>
                   <a:srgbClr val="5A6A80"/>
                 </a:solidFill>
@@ -3739,14 +3775,14 @@
       </p:sp>
       <p:sp>
         <p:nvSpPr>
-          <p:cNvPr id="19" name="Rectangle 18"/>
+          <p:cNvPr id="20" name="Rectangle 19"/>
           <p:cNvSpPr/>
           <p:nvPr/>
         </p:nvSpPr>
         <p:spPr>
           <a:xfrm>
-            <a:off x="457200" y="3364992"/>
-            <a:ext cx="11274552" cy="804672"/>
+            <a:off x="457200" y="4940808"/>
+            <a:ext cx="11274552" cy="1615440"/>
           </a:xfrm>
           <a:prstGeom prst="rect">
             <a:avLst/>
@@ -3784,14 +3820,14 @@
       </p:sp>
       <p:sp>
         <p:nvSpPr>
-          <p:cNvPr id="20" name="TextBox 19"/>
+          <p:cNvPr id="21" name="TextBox 20"/>
           <p:cNvSpPr txBox="1"/>
           <p:nvPr/>
         </p:nvSpPr>
         <p:spPr>
           <a:xfrm>
-            <a:off x="566928" y="3474720"/>
-            <a:ext cx="411480" cy="804672"/>
+            <a:off x="548640" y="5032248"/>
+            <a:ext cx="457200" cy="1615440"/>
           </a:xfrm>
           <a:prstGeom prst="rect">
             <a:avLst/>
@@ -3806,9 +3842,9 @@
           <a:p>
             <a:pPr algn="l"/>
             <a:r>
-              <a:rPr sz="2200" b="1">
-                <a:solidFill>
-                  <a:srgbClr val="DCDCDC"/>
+              <a:rPr sz="2600" b="1">
+                <a:solidFill>
+                  <a:srgbClr val="D7D7D7"/>
                 </a:solidFill>
                 <a:latin typeface="Calibri"/>
               </a:rPr>
@@ -3819,14 +3855,14 @@
       </p:sp>
       <p:sp>
         <p:nvSpPr>
-          <p:cNvPr id="21" name="Rectangle 20"/>
+          <p:cNvPr id="22" name="Rectangle 21"/>
           <p:cNvSpPr/>
           <p:nvPr/>
         </p:nvSpPr>
         <p:spPr>
           <a:xfrm>
-            <a:off x="1005840" y="3456432"/>
-            <a:ext cx="1554480" cy="201168"/>
+            <a:off x="1024128" y="5032248"/>
+            <a:ext cx="1920240" cy="237744"/>
           </a:xfrm>
           <a:prstGeom prst="rect">
             <a:avLst/>
@@ -3862,14 +3898,14 @@
       </p:sp>
       <p:sp>
         <p:nvSpPr>
-          <p:cNvPr id="22" name="TextBox 21"/>
+          <p:cNvPr id="23" name="TextBox 22"/>
           <p:cNvSpPr txBox="1"/>
           <p:nvPr/>
         </p:nvSpPr>
         <p:spPr>
           <a:xfrm>
-            <a:off x="1060704" y="3456432"/>
-            <a:ext cx="1554480" cy="201168"/>
+            <a:off x="1115568" y="5068824"/>
+            <a:ext cx="1920240" cy="237744"/>
           </a:xfrm>
           <a:prstGeom prst="rect">
             <a:avLst/>
@@ -3884,7 +3920,7 @@
           <a:p>
             <a:pPr algn="l"/>
             <a:r>
-              <a:rPr sz="700" b="1">
+              <a:rPr sz="800" b="1">
                 <a:solidFill>
                   <a:srgbClr val="1A6FA8"/>
                 </a:solidFill>
@@ -3897,14 +3933,14 @@
       </p:sp>
       <p:sp>
         <p:nvSpPr>
-          <p:cNvPr id="23" name="TextBox 22"/>
+          <p:cNvPr id="24" name="TextBox 23"/>
           <p:cNvSpPr txBox="1"/>
           <p:nvPr/>
         </p:nvSpPr>
         <p:spPr>
           <a:xfrm>
-            <a:off x="1005840" y="3666744"/>
-            <a:ext cx="10588752" cy="256032"/>
+            <a:off x="1024128" y="5288280"/>
+            <a:ext cx="10561320" cy="329184"/>
           </a:xfrm>
           <a:prstGeom prst="rect">
             <a:avLst/>
@@ -3919,7 +3955,7 @@
           <a:p>
             <a:pPr algn="l"/>
             <a:r>
-              <a:rPr sz="1100" b="1">
+              <a:rPr sz="1300" b="1">
                 <a:solidFill>
                   <a:srgbClr val="1A1A2E"/>
                 </a:solidFill>
@@ -3932,14 +3968,14 @@
       </p:sp>
       <p:sp>
         <p:nvSpPr>
-          <p:cNvPr id="24" name="TextBox 23"/>
+          <p:cNvPr id="25" name="TextBox 24"/>
           <p:cNvSpPr txBox="1"/>
           <p:nvPr/>
         </p:nvSpPr>
         <p:spPr>
           <a:xfrm>
-            <a:off x="1005840" y="3895344"/>
-            <a:ext cx="10588752" cy="274320"/>
+            <a:off x="1024128" y="5599176"/>
+            <a:ext cx="10561320" cy="902208"/>
           </a:xfrm>
           <a:prstGeom prst="rect">
             <a:avLst/>
@@ -3954,7 +3990,7 @@
           <a:p>
             <a:pPr algn="l"/>
             <a:r>
-              <a:rPr sz="800" b="0">
+              <a:rPr sz="1000" b="0">
                 <a:solidFill>
                   <a:srgbClr val="5A6A80"/>
                 </a:solidFill>
@@ -3967,25 +4003,23 @@
       </p:sp>
       <p:sp>
         <p:nvSpPr>
-          <p:cNvPr id="25" name="Rectangle 24"/>
+          <p:cNvPr id="26" name="Rectangle 25"/>
           <p:cNvSpPr/>
           <p:nvPr/>
         </p:nvSpPr>
         <p:spPr>
           <a:xfrm>
-            <a:off x="457200" y="4233672"/>
-            <a:ext cx="11274552" cy="804672"/>
+            <a:off x="0" y="6583680"/>
+            <a:ext cx="12188952" cy="274320"/>
           </a:xfrm>
           <a:prstGeom prst="rect">
             <a:avLst/>
           </a:prstGeom>
           <a:solidFill>
-            <a:srgbClr val="FFFFFF"/>
+            <a:srgbClr val="F7F8FA"/>
           </a:solidFill>
-          <a:ln w="9525">
-            <a:solidFill>
-              <a:srgbClr val="DCE1EB"/>
-            </a:solidFill>
+          <a:ln>
+            <a:noFill/>
           </a:ln>
         </p:spPr>
         <p:style>
@@ -4012,14 +4046,14 @@
       </p:sp>
       <p:sp>
         <p:nvSpPr>
-          <p:cNvPr id="26" name="TextBox 25"/>
+          <p:cNvPr id="27" name="TextBox 26"/>
           <p:cNvSpPr txBox="1"/>
           <p:nvPr/>
         </p:nvSpPr>
         <p:spPr>
           <a:xfrm>
-            <a:off x="566928" y="4343400"/>
-            <a:ext cx="411480" cy="804672"/>
+            <a:off x="457200" y="6638544"/>
+            <a:ext cx="4572000" cy="274320"/>
           </a:xfrm>
           <a:prstGeom prst="rect">
             <a:avLst/>
@@ -4034,33 +4068,86 @@
           <a:p>
             <a:pPr algn="l"/>
             <a:r>
-              <a:rPr sz="2200" b="1">
-                <a:solidFill>
-                  <a:srgbClr val="DCDCDC"/>
+              <a:rPr sz="900" b="0">
+                <a:solidFill>
+                  <a:srgbClr val="AAAAAA"/>
                 </a:solidFill>
                 <a:latin typeface="Calibri"/>
               </a:rPr>
-              <a:t>04</a:t>
-            </a:r>
-          </a:p>
-        </p:txBody>
-      </p:sp>
-      <p:sp>
-        <p:nvSpPr>
-          <p:cNvPr id="27" name="Rectangle 26"/>
+              <a:t>Kooperationspartner: NEOH GmbH</a:t>
+            </a:r>
+          </a:p>
+        </p:txBody>
+      </p:sp>
+      <p:sp>
+        <p:nvSpPr>
+          <p:cNvPr id="28" name="TextBox 27"/>
+          <p:cNvSpPr txBox="1"/>
+          <p:nvPr/>
+        </p:nvSpPr>
+        <p:spPr>
+          <a:xfrm>
+            <a:off x="10360152" y="6638544"/>
+            <a:ext cx="1645920" cy="274320"/>
+          </a:xfrm>
+          <a:prstGeom prst="rect">
+            <a:avLst/>
+          </a:prstGeom>
+          <a:noFill/>
+        </p:spPr>
+        <p:txBody>
+          <a:bodyPr wrap="square">
+            <a:spAutoFit/>
+          </a:bodyPr>
+          <a:lstStyle/>
+          <a:p>
+            <a:pPr algn="r"/>
+            <a:r>
+              <a:rPr sz="900" b="0">
+                <a:solidFill>
+                  <a:srgbClr val="AAAAAA"/>
+                </a:solidFill>
+                <a:latin typeface="Calibri"/>
+              </a:rPr>
+              <a:t>Stand: Mai 2026</a:t>
+            </a:r>
+          </a:p>
+        </p:txBody>
+      </p:sp>
+    </p:spTree>
+  </p:cSld>
+  <p:clrMapOvr>
+    <a:masterClrMapping/>
+  </p:clrMapOvr>
+</p:sld>
+</file>
+
+<file path=ppt/slides/slide2.xml><?xml version="1.0" encoding="utf-8"?>
+<p:sld xmlns:a="http://schemas.openxmlformats.org/drawingml/2006/main" xmlns:p="http://schemas.openxmlformats.org/presentationml/2006/main" xmlns:r="http://schemas.openxmlformats.org/officeDocument/2006/relationships">
+  <p:cSld>
+    <p:spTree>
+      <p:nvGrpSpPr>
+        <p:cNvPr id="1" name=""/>
+        <p:cNvGrpSpPr/>
+        <p:nvPr/>
+      </p:nvGrpSpPr>
+      <p:grpSpPr/>
+      <p:sp>
+        <p:nvSpPr>
+          <p:cNvPr id="2" name="Rectangle 1"/>
           <p:cNvSpPr/>
           <p:nvPr/>
         </p:nvSpPr>
         <p:spPr>
           <a:xfrm>
-            <a:off x="1005840" y="4325112"/>
-            <a:ext cx="1554480" cy="201168"/>
+            <a:off x="0" y="0"/>
+            <a:ext cx="12188952" cy="1417320"/>
           </a:xfrm>
           <a:prstGeom prst="rect">
             <a:avLst/>
           </a:prstGeom>
           <a:solidFill>
-            <a:srgbClr val="EAF7EF"/>
+            <a:srgbClr val="1A1A2E"/>
           </a:solidFill>
           <a:ln>
             <a:noFill/>
@@ -4090,14 +4177,14 @@
       </p:sp>
       <p:sp>
         <p:nvSpPr>
-          <p:cNvPr id="28" name="TextBox 27"/>
+          <p:cNvPr id="3" name="TextBox 2"/>
           <p:cNvSpPr txBox="1"/>
           <p:nvPr/>
         </p:nvSpPr>
         <p:spPr>
           <a:xfrm>
-            <a:off x="1060704" y="4325112"/>
-            <a:ext cx="1554480" cy="201168"/>
+            <a:off x="457200" y="146304"/>
+            <a:ext cx="11274552" cy="475488"/>
           </a:xfrm>
           <a:prstGeom prst="rect">
             <a:avLst/>
@@ -4112,27 +4199,27 @@
           <a:p>
             <a:pPr algn="l"/>
             <a:r>
-              <a:rPr sz="700" b="1">
-                <a:solidFill>
-                  <a:srgbClr val="1E7E46"/>
+              <a:rPr sz="3000" b="1">
+                <a:solidFill>
+                  <a:srgbClr val="FFFFFF"/>
                 </a:solidFill>
                 <a:latin typeface="Calibri"/>
               </a:rPr>
-              <a:t>BRAND GROWTH</a:t>
-            </a:r>
-          </a:p>
-        </p:txBody>
-      </p:sp>
-      <p:sp>
-        <p:nvSpPr>
-          <p:cNvPr id="29" name="TextBox 28"/>
+              <a:t>Masterarbeitsthemen</a:t>
+            </a:r>
+          </a:p>
+        </p:txBody>
+      </p:sp>
+      <p:sp>
+        <p:nvSpPr>
+          <p:cNvPr id="4" name="TextBox 3"/>
           <p:cNvSpPr txBox="1"/>
           <p:nvPr/>
         </p:nvSpPr>
         <p:spPr>
           <a:xfrm>
-            <a:off x="1005840" y="4535424"/>
-            <a:ext cx="10588752" cy="256032"/>
+            <a:off x="457200" y="603504"/>
+            <a:ext cx="11274552" cy="274320"/>
           </a:xfrm>
           <a:prstGeom prst="rect">
             <a:avLst/>
@@ -4147,27 +4234,27 @@
           <a:p>
             <a:pPr algn="l"/>
             <a:r>
-              <a:rPr sz="1100" b="1">
-                <a:solidFill>
-                  <a:srgbClr val="1A1A2E"/>
+              <a:rPr sz="1200" b="0">
+                <a:solidFill>
+                  <a:srgbClr val="B4B4C8"/>
                 </a:solidFill>
                 <a:latin typeface="Calibri"/>
               </a:rPr>
-              <a:t>How Small Brands Grow (Internationally)</a:t>
-            </a:r>
-          </a:p>
-        </p:txBody>
-      </p:sp>
-      <p:sp>
-        <p:nvSpPr>
-          <p:cNvPr id="30" name="TextBox 29"/>
+              <a:t>Betreute Abschlussarbeiten · Ausschreibung 2026</a:t>
+            </a:r>
+          </a:p>
+        </p:txBody>
+      </p:sp>
+      <p:sp>
+        <p:nvSpPr>
+          <p:cNvPr id="5" name="TextBox 4"/>
           <p:cNvSpPr txBox="1"/>
           <p:nvPr/>
         </p:nvSpPr>
         <p:spPr>
           <a:xfrm>
-            <a:off x="1005840" y="4764024"/>
-            <a:ext cx="10588752" cy="274320"/>
+            <a:off x="11091672" y="91440"/>
+            <a:ext cx="914400" cy="274320"/>
           </a:xfrm>
           <a:prstGeom prst="rect">
             <a:avLst/>
@@ -4180,29 +4267,29 @@
           </a:bodyPr>
           <a:lstStyle/>
           <a:p>
-            <a:pPr algn="l"/>
-            <a:r>
-              <a:rPr sz="800" b="0">
-                <a:solidFill>
-                  <a:srgbClr val="5A6A80"/>
+            <a:pPr algn="r"/>
+            <a:r>
+              <a:rPr sz="1000" b="0">
+                <a:solidFill>
+                  <a:srgbClr val="8C8CAA"/>
                 </a:solidFill>
                 <a:latin typeface="Calibri"/>
               </a:rPr>
-              <a:t>Empirische Analyse der Wachstumsstrategien kleiner Marken im nationalen und internationalen Kontext — unter Berücksichtigung von Markenbekanntheit, Distributionsaufbau, Positionierung und den Gesetzmäßigkeiten des empirischen Marketings (z. B. Ehrenberg-Bass).</a:t>
-            </a:r>
-          </a:p>
-        </p:txBody>
-      </p:sp>
-      <p:sp>
-        <p:nvSpPr>
-          <p:cNvPr id="31" name="Rectangle 30"/>
+              <a:t>2 / 2</a:t>
+            </a:r>
+          </a:p>
+        </p:txBody>
+      </p:sp>
+      <p:sp>
+        <p:nvSpPr>
+          <p:cNvPr id="6" name="Rectangle 5"/>
           <p:cNvSpPr/>
           <p:nvPr/>
         </p:nvSpPr>
         <p:spPr>
           <a:xfrm>
-            <a:off x="457200" y="5102352"/>
-            <a:ext cx="11274552" cy="804672"/>
+            <a:off x="457200" y="1527048"/>
+            <a:ext cx="11274552" cy="1426464"/>
           </a:xfrm>
           <a:prstGeom prst="rect">
             <a:avLst/>
@@ -4240,14 +4327,14 @@
       </p:sp>
       <p:sp>
         <p:nvSpPr>
-          <p:cNvPr id="32" name="TextBox 31"/>
+          <p:cNvPr id="7" name="TextBox 6"/>
           <p:cNvSpPr txBox="1"/>
           <p:nvPr/>
         </p:nvSpPr>
         <p:spPr>
           <a:xfrm>
-            <a:off x="566928" y="5212080"/>
-            <a:ext cx="411480" cy="804672"/>
+            <a:off x="548640" y="1618488"/>
+            <a:ext cx="457200" cy="1426464"/>
           </a:xfrm>
           <a:prstGeom prst="rect">
             <a:avLst/>
@@ -4262,33 +4349,33 @@
           <a:p>
             <a:pPr algn="l"/>
             <a:r>
-              <a:rPr sz="2200" b="1">
-                <a:solidFill>
-                  <a:srgbClr val="DCDCDC"/>
+              <a:rPr sz="2600" b="1">
+                <a:solidFill>
+                  <a:srgbClr val="D7D7D7"/>
                 </a:solidFill>
                 <a:latin typeface="Calibri"/>
               </a:rPr>
-              <a:t>05</a:t>
-            </a:r>
-          </a:p>
-        </p:txBody>
-      </p:sp>
-      <p:sp>
-        <p:nvSpPr>
-          <p:cNvPr id="33" name="Rectangle 32"/>
+              <a:t>04</a:t>
+            </a:r>
+          </a:p>
+        </p:txBody>
+      </p:sp>
+      <p:sp>
+        <p:nvSpPr>
+          <p:cNvPr id="8" name="Rectangle 7"/>
           <p:cNvSpPr/>
           <p:nvPr/>
         </p:nvSpPr>
         <p:spPr>
           <a:xfrm>
-            <a:off x="1005840" y="5193792"/>
-            <a:ext cx="1554480" cy="201168"/>
+            <a:off x="1024128" y="1618488"/>
+            <a:ext cx="1920240" cy="237744"/>
           </a:xfrm>
           <a:prstGeom prst="rect">
             <a:avLst/>
           </a:prstGeom>
           <a:solidFill>
-            <a:srgbClr val="F3EEFF"/>
+            <a:srgbClr val="EAF7EF"/>
           </a:solidFill>
           <a:ln>
             <a:noFill/>
@@ -4318,14 +4405,14 @@
       </p:sp>
       <p:sp>
         <p:nvSpPr>
-          <p:cNvPr id="34" name="TextBox 33"/>
+          <p:cNvPr id="9" name="TextBox 8"/>
           <p:cNvSpPr txBox="1"/>
           <p:nvPr/>
         </p:nvSpPr>
         <p:spPr>
           <a:xfrm>
-            <a:off x="1060704" y="5193792"/>
-            <a:ext cx="1554480" cy="201168"/>
+            <a:off x="1115568" y="1655064"/>
+            <a:ext cx="1920240" cy="237744"/>
           </a:xfrm>
           <a:prstGeom prst="rect">
             <a:avLst/>
@@ -4340,27 +4427,27 @@
           <a:p>
             <a:pPr algn="l"/>
             <a:r>
-              <a:rPr sz="700" b="1">
-                <a:solidFill>
-                  <a:srgbClr val="6B3FA0"/>
+              <a:rPr sz="800" b="1">
+                <a:solidFill>
+                  <a:srgbClr val="1E7E46"/>
                 </a:solidFill>
                 <a:latin typeface="Calibri"/>
               </a:rPr>
-              <a:t>REPLIKATION</a:t>
-            </a:r>
-          </a:p>
-        </p:txBody>
-      </p:sp>
-      <p:sp>
-        <p:nvSpPr>
-          <p:cNvPr id="35" name="TextBox 34"/>
+              <a:t>BRAND GROWTH</a:t>
+            </a:r>
+          </a:p>
+        </p:txBody>
+      </p:sp>
+      <p:sp>
+        <p:nvSpPr>
+          <p:cNvPr id="10" name="TextBox 9"/>
           <p:cNvSpPr txBox="1"/>
           <p:nvPr/>
         </p:nvSpPr>
         <p:spPr>
           <a:xfrm>
-            <a:off x="1005840" y="5404104"/>
-            <a:ext cx="10588752" cy="256032"/>
+            <a:off x="1024128" y="1874520"/>
+            <a:ext cx="10561320" cy="329184"/>
           </a:xfrm>
           <a:prstGeom prst="rect">
             <a:avLst/>
@@ -4375,27 +4462,27 @@
           <a:p>
             <a:pPr algn="l"/>
             <a:r>
-              <a:rPr sz="1100" b="1">
+              <a:rPr sz="1300" b="1">
                 <a:solidFill>
                   <a:srgbClr val="1A1A2E"/>
                 </a:solidFill>
                 <a:latin typeface="Calibri"/>
               </a:rPr>
-              <a:t>Replikationsstudien</a:t>
-            </a:r>
-          </a:p>
-        </p:txBody>
-      </p:sp>
-      <p:sp>
-        <p:nvSpPr>
-          <p:cNvPr id="36" name="TextBox 35"/>
+              <a:t>How Small Brands Grow (Internationally)</a:t>
+            </a:r>
+          </a:p>
+        </p:txBody>
+      </p:sp>
+      <p:sp>
+        <p:nvSpPr>
+          <p:cNvPr id="11" name="TextBox 10"/>
           <p:cNvSpPr txBox="1"/>
           <p:nvPr/>
         </p:nvSpPr>
         <p:spPr>
           <a:xfrm>
-            <a:off x="1005840" y="5632704"/>
-            <a:ext cx="10588752" cy="274320"/>
+            <a:off x="1024128" y="2185416"/>
+            <a:ext cx="10561320" cy="713232"/>
           </a:xfrm>
           <a:prstGeom prst="rect">
             <a:avLst/>
@@ -4410,37 +4497,37 @@
           <a:p>
             <a:pPr algn="l"/>
             <a:r>
-              <a:rPr sz="800" b="0">
+              <a:rPr sz="1000" b="0">
                 <a:solidFill>
                   <a:srgbClr val="5A6A80"/>
                 </a:solidFill>
                 <a:latin typeface="Calibri"/>
               </a:rPr>
-              <a:t>Empirische Replikation bestehender Studien aus dem Bereich Marketing oder internationales Business — zur Überprüfung der Generalisierbarkeit von Befunden in neuen Kontexten, Märkten oder Zeiträumen.</a:t>
-            </a:r>
-          </a:p>
-        </p:txBody>
-      </p:sp>
-      <p:sp>
-        <p:nvSpPr>
-          <p:cNvPr id="37" name="Rectangle 36"/>
+              <a:t>Empirische Analyse der Wachstumsstrategien kleiner Marken im nationalen und internationalen Kontext — unter Berücksichtigung von Markenbekanntheit, Distributionsaufbau, Positionierung und den Gesetzmäßigkeiten des empirischen Marketings (z. B. Ehrenberg-Bass).</a:t>
+            </a:r>
+          </a:p>
+        </p:txBody>
+      </p:sp>
+      <p:sp>
+        <p:nvSpPr>
+          <p:cNvPr id="12" name="Rectangle 11"/>
           <p:cNvSpPr/>
           <p:nvPr/>
         </p:nvSpPr>
         <p:spPr>
           <a:xfrm>
-            <a:off x="457200" y="6062472"/>
-            <a:ext cx="11274552" cy="475488"/>
+            <a:off x="457200" y="3044952"/>
+            <a:ext cx="11274552" cy="1426464"/>
           </a:xfrm>
           <a:prstGeom prst="rect">
             <a:avLst/>
           </a:prstGeom>
           <a:solidFill>
-            <a:srgbClr val="F7F8FA"/>
+            <a:srgbClr val="FFFFFF"/>
           </a:solidFill>
           <a:ln w="9525">
             <a:solidFill>
-              <a:srgbClr val="E4E8EE"/>
+              <a:srgbClr val="DCE1EB"/>
             </a:solidFill>
           </a:ln>
         </p:spPr>
@@ -4468,14 +4555,14 @@
       </p:sp>
       <p:sp>
         <p:nvSpPr>
-          <p:cNvPr id="38" name="TextBox 37"/>
+          <p:cNvPr id="13" name="TextBox 12"/>
           <p:cNvSpPr txBox="1"/>
           <p:nvPr/>
         </p:nvSpPr>
         <p:spPr>
           <a:xfrm>
-            <a:off x="621792" y="6108192"/>
-            <a:ext cx="11274552" cy="164592"/>
+            <a:off x="548640" y="3136392"/>
+            <a:ext cx="457200" cy="1426464"/>
           </a:xfrm>
           <a:prstGeom prst="rect">
             <a:avLst/>
@@ -4490,68 +4577,33 @@
           <a:p>
             <a:pPr algn="l"/>
             <a:r>
-              <a:rPr sz="700" b="1">
-                <a:solidFill>
-                  <a:srgbClr val="8A96A8"/>
+              <a:rPr sz="2600" b="1">
+                <a:solidFill>
+                  <a:srgbClr val="D7D7D7"/>
                 </a:solidFill>
                 <a:latin typeface="Calibri"/>
               </a:rPr>
-              <a:t>ALLGEMEINE HINWEISE</a:t>
-            </a:r>
-          </a:p>
-        </p:txBody>
-      </p:sp>
-      <p:sp>
-        <p:nvSpPr>
-          <p:cNvPr id="39" name="TextBox 38"/>
-          <p:cNvSpPr txBox="1"/>
-          <p:nvPr/>
-        </p:nvSpPr>
-        <p:spPr>
-          <a:xfrm>
-            <a:off x="621792" y="6263640"/>
-            <a:ext cx="11274552" cy="128016"/>
-          </a:xfrm>
-          <a:prstGeom prst="rect">
-            <a:avLst/>
-          </a:prstGeom>
-          <a:noFill/>
-        </p:spPr>
-        <p:txBody>
-          <a:bodyPr wrap="square">
-            <a:spAutoFit/>
-          </a:bodyPr>
-          <a:lstStyle/>
-          <a:p>
-            <a:pPr algn="l"/>
-            <a:r>
-              <a:rPr sz="900" b="0">
-                <a:solidFill>
-                  <a:srgbClr val="4A5568"/>
-                </a:solidFill>
-                <a:latin typeface="Calibri"/>
-              </a:rPr>
-              <a:t>✦  Es werden nur empirische Arbeiten betreut (qualitativ oder quantitativ).    ✦  Die Arbeiten können auf Deutsch oder Englisch verfasst werden.</a:t>
-            </a:r>
-          </a:p>
-        </p:txBody>
-      </p:sp>
-      <p:sp>
-        <p:nvSpPr>
-          <p:cNvPr id="40" name="Rectangle 39"/>
+              <a:t>05</a:t>
+            </a:r>
+          </a:p>
+        </p:txBody>
+      </p:sp>
+      <p:sp>
+        <p:nvSpPr>
+          <p:cNvPr id="14" name="Rectangle 13"/>
           <p:cNvSpPr/>
           <p:nvPr/>
         </p:nvSpPr>
         <p:spPr>
           <a:xfrm>
-            <a:off x="0" y="6601968"/>
-            <a:ext cx="12188952" cy="256032"/>
+            <a:off x="1024128" y="3136392"/>
+            <a:ext cx="1920240" cy="237744"/>
           </a:xfrm>
           <a:prstGeom prst="rect">
             <a:avLst/>
           </a:prstGeom>
           <a:solidFill>
-            <a:srgbClr val="F7F8FA"/>
+            <a:srgbClr val="FFEBEB"/>
           </a:solidFill>
           <a:ln>
             <a:noFill/>
@@ -4581,14 +4633,14 @@
       </p:sp>
       <p:sp>
         <p:nvSpPr>
-          <p:cNvPr id="41" name="TextBox 40"/>
+          <p:cNvPr id="15" name="TextBox 14"/>
           <p:cNvSpPr txBox="1"/>
           <p:nvPr/>
         </p:nvSpPr>
         <p:spPr>
           <a:xfrm>
-            <a:off x="457200" y="6647688"/>
-            <a:ext cx="3657600" cy="256032"/>
+            <a:off x="1115568" y="3172968"/>
+            <a:ext cx="1920240" cy="237744"/>
           </a:xfrm>
           <a:prstGeom prst="rect">
             <a:avLst/>
@@ -4603,7 +4655,498 @@
           <a:p>
             <a:pPr algn="l"/>
             <a:r>
-              <a:rPr sz="800" b="0">
+              <a:rPr sz="800" b="1">
+                <a:solidFill>
+                  <a:srgbClr val="B43C3C"/>
+                </a:solidFill>
+                <a:latin typeface="Calibri"/>
+              </a:rPr>
+              <a:t>BRAND COMMUNICATIONS</a:t>
+            </a:r>
+          </a:p>
+        </p:txBody>
+      </p:sp>
+      <p:sp>
+        <p:nvSpPr>
+          <p:cNvPr id="16" name="TextBox 15"/>
+          <p:cNvSpPr txBox="1"/>
+          <p:nvPr/>
+        </p:nvSpPr>
+        <p:spPr>
+          <a:xfrm>
+            <a:off x="1024128" y="3392424"/>
+            <a:ext cx="10561320" cy="329184"/>
+          </a:xfrm>
+          <a:prstGeom prst="rect">
+            <a:avLst/>
+          </a:prstGeom>
+          <a:noFill/>
+        </p:spPr>
+        <p:txBody>
+          <a:bodyPr wrap="square">
+            <a:spAutoFit/>
+          </a:bodyPr>
+          <a:lstStyle/>
+          <a:p>
+            <a:pPr algn="l"/>
+            <a:r>
+              <a:rPr sz="1300" b="1">
+                <a:solidFill>
+                  <a:srgbClr val="1A1A2E"/>
+                </a:solidFill>
+                <a:latin typeface="Calibri"/>
+              </a:rPr>
+              <a:t>(International) Brand Communications: Brand Engagement &amp; Brand Communities</a:t>
+            </a:r>
+          </a:p>
+        </p:txBody>
+      </p:sp>
+      <p:sp>
+        <p:nvSpPr>
+          <p:cNvPr id="17" name="TextBox 16"/>
+          <p:cNvSpPr txBox="1"/>
+          <p:nvPr/>
+        </p:nvSpPr>
+        <p:spPr>
+          <a:xfrm>
+            <a:off x="1024128" y="3703320"/>
+            <a:ext cx="10561320" cy="713232"/>
+          </a:xfrm>
+          <a:prstGeom prst="rect">
+            <a:avLst/>
+          </a:prstGeom>
+          <a:noFill/>
+        </p:spPr>
+        <p:txBody>
+          <a:bodyPr wrap="square">
+            <a:spAutoFit/>
+          </a:bodyPr>
+          <a:lstStyle/>
+          <a:p>
+            <a:pPr algn="l"/>
+            <a:r>
+              <a:rPr sz="1000" b="0">
+                <a:solidFill>
+                  <a:srgbClr val="5A6A80"/>
+                </a:solidFill>
+                <a:latin typeface="Calibri"/>
+              </a:rPr>
+              <a:t>Empirische Untersuchung internationaler Markenkommunikation mit Fokus auf Brand Engagement und Brand Communities — z. B. Aufbau und Pflege von Markengemeinschaften, Engagement-Treiber und deren Wirkung auf Markenloyalität und -identifikation.</a:t>
+            </a:r>
+          </a:p>
+        </p:txBody>
+      </p:sp>
+      <p:sp>
+        <p:nvSpPr>
+          <p:cNvPr id="18" name="Rectangle 17"/>
+          <p:cNvSpPr/>
+          <p:nvPr/>
+        </p:nvSpPr>
+        <p:spPr>
+          <a:xfrm>
+            <a:off x="457200" y="4562856"/>
+            <a:ext cx="11274552" cy="1426464"/>
+          </a:xfrm>
+          <a:prstGeom prst="rect">
+            <a:avLst/>
+          </a:prstGeom>
+          <a:solidFill>
+            <a:srgbClr val="FFFFFF"/>
+          </a:solidFill>
+          <a:ln w="9525">
+            <a:solidFill>
+              <a:srgbClr val="DCE1EB"/>
+            </a:solidFill>
+          </a:ln>
+        </p:spPr>
+        <p:style>
+          <a:lnRef idx="1">
+            <a:schemeClr val="accent1"/>
+          </a:lnRef>
+          <a:fillRef idx="3">
+            <a:schemeClr val="accent1"/>
+          </a:fillRef>
+          <a:effectRef idx="2">
+            <a:schemeClr val="accent1"/>
+          </a:effectRef>
+          <a:fontRef idx="minor">
+            <a:schemeClr val="lt1"/>
+          </a:fontRef>
+        </p:style>
+        <p:txBody>
+          <a:bodyPr rtlCol="0" anchor="ctr"/>
+          <a:lstStyle/>
+          <a:p>
+            <a:pPr algn="ctr"/>
+          </a:p>
+        </p:txBody>
+      </p:sp>
+      <p:sp>
+        <p:nvSpPr>
+          <p:cNvPr id="19" name="TextBox 18"/>
+          <p:cNvSpPr txBox="1"/>
+          <p:nvPr/>
+        </p:nvSpPr>
+        <p:spPr>
+          <a:xfrm>
+            <a:off x="548640" y="4654296"/>
+            <a:ext cx="457200" cy="1426464"/>
+          </a:xfrm>
+          <a:prstGeom prst="rect">
+            <a:avLst/>
+          </a:prstGeom>
+          <a:noFill/>
+        </p:spPr>
+        <p:txBody>
+          <a:bodyPr wrap="square">
+            <a:spAutoFit/>
+          </a:bodyPr>
+          <a:lstStyle/>
+          <a:p>
+            <a:pPr algn="l"/>
+            <a:r>
+              <a:rPr sz="2600" b="1">
+                <a:solidFill>
+                  <a:srgbClr val="D7D7D7"/>
+                </a:solidFill>
+                <a:latin typeface="Calibri"/>
+              </a:rPr>
+              <a:t>06</a:t>
+            </a:r>
+          </a:p>
+        </p:txBody>
+      </p:sp>
+      <p:sp>
+        <p:nvSpPr>
+          <p:cNvPr id="20" name="Rectangle 19"/>
+          <p:cNvSpPr/>
+          <p:nvPr/>
+        </p:nvSpPr>
+        <p:spPr>
+          <a:xfrm>
+            <a:off x="1024128" y="4654296"/>
+            <a:ext cx="1920240" cy="237744"/>
+          </a:xfrm>
+          <a:prstGeom prst="rect">
+            <a:avLst/>
+          </a:prstGeom>
+          <a:solidFill>
+            <a:srgbClr val="F3EEFF"/>
+          </a:solidFill>
+          <a:ln>
+            <a:noFill/>
+          </a:ln>
+        </p:spPr>
+        <p:style>
+          <a:lnRef idx="1">
+            <a:schemeClr val="accent1"/>
+          </a:lnRef>
+          <a:fillRef idx="3">
+            <a:schemeClr val="accent1"/>
+          </a:fillRef>
+          <a:effectRef idx="2">
+            <a:schemeClr val="accent1"/>
+          </a:effectRef>
+          <a:fontRef idx="minor">
+            <a:schemeClr val="lt1"/>
+          </a:fontRef>
+        </p:style>
+        <p:txBody>
+          <a:bodyPr rtlCol="0" anchor="ctr"/>
+          <a:lstStyle/>
+          <a:p>
+            <a:pPr algn="ctr"/>
+          </a:p>
+        </p:txBody>
+      </p:sp>
+      <p:sp>
+        <p:nvSpPr>
+          <p:cNvPr id="21" name="TextBox 20"/>
+          <p:cNvSpPr txBox="1"/>
+          <p:nvPr/>
+        </p:nvSpPr>
+        <p:spPr>
+          <a:xfrm>
+            <a:off x="1115568" y="4690872"/>
+            <a:ext cx="1920240" cy="237744"/>
+          </a:xfrm>
+          <a:prstGeom prst="rect">
+            <a:avLst/>
+          </a:prstGeom>
+          <a:noFill/>
+        </p:spPr>
+        <p:txBody>
+          <a:bodyPr wrap="square">
+            <a:spAutoFit/>
+          </a:bodyPr>
+          <a:lstStyle/>
+          <a:p>
+            <a:pPr algn="l"/>
+            <a:r>
+              <a:rPr sz="800" b="1">
+                <a:solidFill>
+                  <a:srgbClr val="6B3FA0"/>
+                </a:solidFill>
+                <a:latin typeface="Calibri"/>
+              </a:rPr>
+              <a:t>REPLIKATION</a:t>
+            </a:r>
+          </a:p>
+        </p:txBody>
+      </p:sp>
+      <p:sp>
+        <p:nvSpPr>
+          <p:cNvPr id="22" name="TextBox 21"/>
+          <p:cNvSpPr txBox="1"/>
+          <p:nvPr/>
+        </p:nvSpPr>
+        <p:spPr>
+          <a:xfrm>
+            <a:off x="1024128" y="4910328"/>
+            <a:ext cx="10561320" cy="329184"/>
+          </a:xfrm>
+          <a:prstGeom prst="rect">
+            <a:avLst/>
+          </a:prstGeom>
+          <a:noFill/>
+        </p:spPr>
+        <p:txBody>
+          <a:bodyPr wrap="square">
+            <a:spAutoFit/>
+          </a:bodyPr>
+          <a:lstStyle/>
+          <a:p>
+            <a:pPr algn="l"/>
+            <a:r>
+              <a:rPr sz="1300" b="1">
+                <a:solidFill>
+                  <a:srgbClr val="1A1A2E"/>
+                </a:solidFill>
+                <a:latin typeface="Calibri"/>
+              </a:rPr>
+              <a:t>Replikationsstudien</a:t>
+            </a:r>
+          </a:p>
+        </p:txBody>
+      </p:sp>
+      <p:sp>
+        <p:nvSpPr>
+          <p:cNvPr id="23" name="TextBox 22"/>
+          <p:cNvSpPr txBox="1"/>
+          <p:nvPr/>
+        </p:nvSpPr>
+        <p:spPr>
+          <a:xfrm>
+            <a:off x="1024128" y="5221224"/>
+            <a:ext cx="10561320" cy="713232"/>
+          </a:xfrm>
+          <a:prstGeom prst="rect">
+            <a:avLst/>
+          </a:prstGeom>
+          <a:noFill/>
+        </p:spPr>
+        <p:txBody>
+          <a:bodyPr wrap="square">
+            <a:spAutoFit/>
+          </a:bodyPr>
+          <a:lstStyle/>
+          <a:p>
+            <a:pPr algn="l"/>
+            <a:r>
+              <a:rPr sz="1000" b="0">
+                <a:solidFill>
+                  <a:srgbClr val="5A6A80"/>
+                </a:solidFill>
+                <a:latin typeface="Calibri"/>
+              </a:rPr>
+              <a:t>Empirische Replikation bestehender Studien aus dem Bereich Marketing oder internationales Business — zur Überprüfung der Generalisierbarkeit von Befunden in neuen Kontexten, Märkten oder Zeiträumen.</a:t>
+            </a:r>
+          </a:p>
+        </p:txBody>
+      </p:sp>
+      <p:sp>
+        <p:nvSpPr>
+          <p:cNvPr id="24" name="Rectangle 23"/>
+          <p:cNvSpPr/>
+          <p:nvPr/>
+        </p:nvSpPr>
+        <p:spPr>
+          <a:xfrm>
+            <a:off x="457200" y="6035040"/>
+            <a:ext cx="11274552" cy="493776"/>
+          </a:xfrm>
+          <a:prstGeom prst="rect">
+            <a:avLst/>
+          </a:prstGeom>
+          <a:solidFill>
+            <a:srgbClr val="F7F8FA"/>
+          </a:solidFill>
+          <a:ln w="9525">
+            <a:solidFill>
+              <a:srgbClr val="E4E8EE"/>
+            </a:solidFill>
+          </a:ln>
+        </p:spPr>
+        <p:style>
+          <a:lnRef idx="1">
+            <a:schemeClr val="accent1"/>
+          </a:lnRef>
+          <a:fillRef idx="3">
+            <a:schemeClr val="accent1"/>
+          </a:fillRef>
+          <a:effectRef idx="2">
+            <a:schemeClr val="accent1"/>
+          </a:effectRef>
+          <a:fontRef idx="minor">
+            <a:schemeClr val="lt1"/>
+          </a:fontRef>
+        </p:style>
+        <p:txBody>
+          <a:bodyPr rtlCol="0" anchor="ctr"/>
+          <a:lstStyle/>
+          <a:p>
+            <a:pPr algn="ctr"/>
+          </a:p>
+        </p:txBody>
+      </p:sp>
+      <p:sp>
+        <p:nvSpPr>
+          <p:cNvPr id="25" name="TextBox 24"/>
+          <p:cNvSpPr txBox="1"/>
+          <p:nvPr/>
+        </p:nvSpPr>
+        <p:spPr>
+          <a:xfrm>
+            <a:off x="640080" y="6080760"/>
+            <a:ext cx="11274552" cy="164592"/>
+          </a:xfrm>
+          <a:prstGeom prst="rect">
+            <a:avLst/>
+          </a:prstGeom>
+          <a:noFill/>
+        </p:spPr>
+        <p:txBody>
+          <a:bodyPr wrap="square">
+            <a:spAutoFit/>
+          </a:bodyPr>
+          <a:lstStyle/>
+          <a:p>
+            <a:pPr algn="l"/>
+            <a:r>
+              <a:rPr sz="800" b="1">
+                <a:solidFill>
+                  <a:srgbClr val="8A96A8"/>
+                </a:solidFill>
+                <a:latin typeface="Calibri"/>
+              </a:rPr>
+              <a:t>ALLGEMEINE HINWEISE</a:t>
+            </a:r>
+          </a:p>
+        </p:txBody>
+      </p:sp>
+      <p:sp>
+        <p:nvSpPr>
+          <p:cNvPr id="26" name="TextBox 25"/>
+          <p:cNvSpPr txBox="1"/>
+          <p:nvPr/>
+        </p:nvSpPr>
+        <p:spPr>
+          <a:xfrm>
+            <a:off x="640080" y="6254496"/>
+            <a:ext cx="11274552" cy="256032"/>
+          </a:xfrm>
+          <a:prstGeom prst="rect">
+            <a:avLst/>
+          </a:prstGeom>
+          <a:noFill/>
+        </p:spPr>
+        <p:txBody>
+          <a:bodyPr wrap="square">
+            <a:spAutoFit/>
+          </a:bodyPr>
+          <a:lstStyle/>
+          <a:p>
+            <a:pPr algn="l"/>
+            <a:r>
+              <a:rPr sz="1000" b="0">
+                <a:solidFill>
+                  <a:srgbClr val="4A5568"/>
+                </a:solidFill>
+                <a:latin typeface="Calibri"/>
+              </a:rPr>
+              <a:t>✦  Es werden nur empirische Arbeiten betreut (qualitativ oder quantitativ).    ✦  Die Arbeiten können auf Deutsch oder Englisch verfasst werden.</a:t>
+            </a:r>
+          </a:p>
+        </p:txBody>
+      </p:sp>
+      <p:sp>
+        <p:nvSpPr>
+          <p:cNvPr id="27" name="Rectangle 26"/>
+          <p:cNvSpPr/>
+          <p:nvPr/>
+        </p:nvSpPr>
+        <p:spPr>
+          <a:xfrm>
+            <a:off x="0" y="6583680"/>
+            <a:ext cx="12188952" cy="274320"/>
+          </a:xfrm>
+          <a:prstGeom prst="rect">
+            <a:avLst/>
+          </a:prstGeom>
+          <a:solidFill>
+            <a:srgbClr val="F7F8FA"/>
+          </a:solidFill>
+          <a:ln>
+            <a:noFill/>
+          </a:ln>
+        </p:spPr>
+        <p:style>
+          <a:lnRef idx="1">
+            <a:schemeClr val="accent1"/>
+          </a:lnRef>
+          <a:fillRef idx="3">
+            <a:schemeClr val="accent1"/>
+          </a:fillRef>
+          <a:effectRef idx="2">
+            <a:schemeClr val="accent1"/>
+          </a:effectRef>
+          <a:fontRef idx="minor">
+            <a:schemeClr val="lt1"/>
+          </a:fontRef>
+        </p:style>
+        <p:txBody>
+          <a:bodyPr rtlCol="0" anchor="ctr"/>
+          <a:lstStyle/>
+          <a:p>
+            <a:pPr algn="ctr"/>
+          </a:p>
+        </p:txBody>
+      </p:sp>
+      <p:sp>
+        <p:nvSpPr>
+          <p:cNvPr id="28" name="TextBox 27"/>
+          <p:cNvSpPr txBox="1"/>
+          <p:nvPr/>
+        </p:nvSpPr>
+        <p:spPr>
+          <a:xfrm>
+            <a:off x="457200" y="6638544"/>
+            <a:ext cx="4572000" cy="274320"/>
+          </a:xfrm>
+          <a:prstGeom prst="rect">
+            <a:avLst/>
+          </a:prstGeom>
+          <a:noFill/>
+        </p:spPr>
+        <p:txBody>
+          <a:bodyPr wrap="square">
+            <a:spAutoFit/>
+          </a:bodyPr>
+          <a:lstStyle/>
+          <a:p>
+            <a:pPr algn="l"/>
+            <a:r>
+              <a:rPr sz="900" b="0">
                 <a:solidFill>
                   <a:srgbClr val="AAAAAA"/>
                 </a:solidFill>
@@ -4616,14 +5159,14 @@
       </p:sp>
       <p:sp>
         <p:nvSpPr>
-          <p:cNvPr id="42" name="TextBox 41"/>
+          <p:cNvPr id="29" name="TextBox 28"/>
           <p:cNvSpPr txBox="1"/>
           <p:nvPr/>
         </p:nvSpPr>
         <p:spPr>
           <a:xfrm>
-            <a:off x="10360152" y="6647688"/>
-            <a:ext cx="1645920" cy="256032"/>
+            <a:off x="10360152" y="6638544"/>
+            <a:ext cx="1645920" cy="274320"/>
           </a:xfrm>
           <a:prstGeom prst="rect">
             <a:avLst/>
@@ -4638,7 +5181,7 @@
           <a:p>
             <a:pPr algn="r"/>
             <a:r>
-              <a:rPr sz="800" b="0">
+              <a:rPr sz="900" b="0">
                 <a:solidFill>
                   <a:srgbClr val="AAAAAA"/>
                 </a:solidFill>

</xml_diff>

<commit_message>
Increase font sizes throughout both slides
https://claude.ai/code/session_01WrWvRy3cmy4KyPGfUNpCAm
</commit_message>
<xml_diff>
--- a/masterarbeitsthemen.pptx
+++ b/masterarbeitsthemen.pptx
@@ -3156,7 +3156,7 @@
           <a:p>
             <a:pPr algn="l"/>
             <a:r>
-              <a:rPr sz="3000" b="1">
+              <a:rPr sz="3600" b="1">
                 <a:solidFill>
                   <a:srgbClr val="FFFFFF"/>
                 </a:solidFill>
@@ -3191,7 +3191,7 @@
           <a:p>
             <a:pPr algn="l"/>
             <a:r>
-              <a:rPr sz="1200" b="0">
+              <a:rPr sz="1500" b="0">
                 <a:solidFill>
                   <a:srgbClr val="B4B4C8"/>
                 </a:solidFill>
@@ -3271,7 +3271,7 @@
           <a:p>
             <a:pPr algn="l"/>
             <a:r>
-              <a:rPr sz="1000" b="0">
+              <a:rPr sz="1200" b="0">
                 <a:solidFill>
                   <a:srgbClr val="E8C547"/>
                 </a:solidFill>
@@ -3386,7 +3386,7 @@
           <a:p>
             <a:pPr algn="l"/>
             <a:r>
-              <a:rPr sz="2600" b="1">
+              <a:rPr sz="3200" b="1">
                 <a:solidFill>
                   <a:srgbClr val="D7D7D7"/>
                 </a:solidFill>
@@ -3464,7 +3464,7 @@
           <a:p>
             <a:pPr algn="l"/>
             <a:r>
-              <a:rPr sz="800" b="1">
+              <a:rPr sz="1000" b="1">
                 <a:solidFill>
                   <a:srgbClr val="A06400"/>
                 </a:solidFill>
@@ -3499,7 +3499,7 @@
           <a:p>
             <a:pPr algn="l"/>
             <a:r>
-              <a:rPr sz="1300" b="1">
+              <a:rPr sz="1600" b="1">
                 <a:solidFill>
                   <a:srgbClr val="1A1A2E"/>
                 </a:solidFill>
@@ -3534,7 +3534,7 @@
           <a:p>
             <a:pPr algn="l"/>
             <a:r>
-              <a:rPr sz="1000" b="0">
+              <a:rPr sz="1200" b="0">
                 <a:solidFill>
                   <a:srgbClr val="5A6A80"/>
                 </a:solidFill>
@@ -3614,7 +3614,7 @@
           <a:p>
             <a:pPr algn="l"/>
             <a:r>
-              <a:rPr sz="2600" b="1">
+              <a:rPr sz="3200" b="1">
                 <a:solidFill>
                   <a:srgbClr val="D7D7D7"/>
                 </a:solidFill>
@@ -3692,7 +3692,7 @@
           <a:p>
             <a:pPr algn="l"/>
             <a:r>
-              <a:rPr sz="800" b="1">
+              <a:rPr sz="1000" b="1">
                 <a:solidFill>
                   <a:srgbClr val="A06400"/>
                 </a:solidFill>
@@ -3727,7 +3727,7 @@
           <a:p>
             <a:pPr algn="l"/>
             <a:r>
-              <a:rPr sz="1300" b="1">
+              <a:rPr sz="1600" b="1">
                 <a:solidFill>
                   <a:srgbClr val="1A1A2E"/>
                 </a:solidFill>
@@ -3762,7 +3762,7 @@
           <a:p>
             <a:pPr algn="l"/>
             <a:r>
-              <a:rPr sz="1000" b="0">
+              <a:rPr sz="1200" b="0">
                 <a:solidFill>
                   <a:srgbClr val="5A6A80"/>
                 </a:solidFill>
@@ -3842,7 +3842,7 @@
           <a:p>
             <a:pPr algn="l"/>
             <a:r>
-              <a:rPr sz="2600" b="1">
+              <a:rPr sz="3200" b="1">
                 <a:solidFill>
                   <a:srgbClr val="D7D7D7"/>
                 </a:solidFill>
@@ -3920,7 +3920,7 @@
           <a:p>
             <a:pPr algn="l"/>
             <a:r>
-              <a:rPr sz="800" b="1">
+              <a:rPr sz="1000" b="1">
                 <a:solidFill>
                   <a:srgbClr val="1A6FA8"/>
                 </a:solidFill>
@@ -3955,7 +3955,7 @@
           <a:p>
             <a:pPr algn="l"/>
             <a:r>
-              <a:rPr sz="1300" b="1">
+              <a:rPr sz="1600" b="1">
                 <a:solidFill>
                   <a:srgbClr val="1A1A2E"/>
                 </a:solidFill>
@@ -3990,7 +3990,7 @@
           <a:p>
             <a:pPr algn="l"/>
             <a:r>
-              <a:rPr sz="1000" b="0">
+              <a:rPr sz="1200" b="0">
                 <a:solidFill>
                   <a:srgbClr val="5A6A80"/>
                 </a:solidFill>
@@ -4199,7 +4199,7 @@
           <a:p>
             <a:pPr algn="l"/>
             <a:r>
-              <a:rPr sz="3000" b="1">
+              <a:rPr sz="3600" b="1">
                 <a:solidFill>
                   <a:srgbClr val="FFFFFF"/>
                 </a:solidFill>
@@ -4234,7 +4234,7 @@
           <a:p>
             <a:pPr algn="l"/>
             <a:r>
-              <a:rPr sz="1200" b="0">
+              <a:rPr sz="1500" b="0">
                 <a:solidFill>
                   <a:srgbClr val="B4B4C8"/>
                 </a:solidFill>
@@ -4349,7 +4349,7 @@
           <a:p>
             <a:pPr algn="l"/>
             <a:r>
-              <a:rPr sz="2600" b="1">
+              <a:rPr sz="3200" b="1">
                 <a:solidFill>
                   <a:srgbClr val="D7D7D7"/>
                 </a:solidFill>
@@ -4427,7 +4427,7 @@
           <a:p>
             <a:pPr algn="l"/>
             <a:r>
-              <a:rPr sz="800" b="1">
+              <a:rPr sz="1000" b="1">
                 <a:solidFill>
                   <a:srgbClr val="1E7E46"/>
                 </a:solidFill>
@@ -4462,7 +4462,7 @@
           <a:p>
             <a:pPr algn="l"/>
             <a:r>
-              <a:rPr sz="1300" b="1">
+              <a:rPr sz="1600" b="1">
                 <a:solidFill>
                   <a:srgbClr val="1A1A2E"/>
                 </a:solidFill>
@@ -4497,7 +4497,7 @@
           <a:p>
             <a:pPr algn="l"/>
             <a:r>
-              <a:rPr sz="1000" b="0">
+              <a:rPr sz="1200" b="0">
                 <a:solidFill>
                   <a:srgbClr val="5A6A80"/>
                 </a:solidFill>
@@ -4577,7 +4577,7 @@
           <a:p>
             <a:pPr algn="l"/>
             <a:r>
-              <a:rPr sz="2600" b="1">
+              <a:rPr sz="3200" b="1">
                 <a:solidFill>
                   <a:srgbClr val="D7D7D7"/>
                 </a:solidFill>
@@ -4655,7 +4655,7 @@
           <a:p>
             <a:pPr algn="l"/>
             <a:r>
-              <a:rPr sz="800" b="1">
+              <a:rPr sz="1000" b="1">
                 <a:solidFill>
                   <a:srgbClr val="B43C3C"/>
                 </a:solidFill>
@@ -4690,7 +4690,7 @@
           <a:p>
             <a:pPr algn="l"/>
             <a:r>
-              <a:rPr sz="1300" b="1">
+              <a:rPr sz="1600" b="1">
                 <a:solidFill>
                   <a:srgbClr val="1A1A2E"/>
                 </a:solidFill>
@@ -4725,7 +4725,7 @@
           <a:p>
             <a:pPr algn="l"/>
             <a:r>
-              <a:rPr sz="1000" b="0">
+              <a:rPr sz="1200" b="0">
                 <a:solidFill>
                   <a:srgbClr val="5A6A80"/>
                 </a:solidFill>
@@ -4805,7 +4805,7 @@
           <a:p>
             <a:pPr algn="l"/>
             <a:r>
-              <a:rPr sz="2600" b="1">
+              <a:rPr sz="3200" b="1">
                 <a:solidFill>
                   <a:srgbClr val="D7D7D7"/>
                 </a:solidFill>
@@ -4883,7 +4883,7 @@
           <a:p>
             <a:pPr algn="l"/>
             <a:r>
-              <a:rPr sz="800" b="1">
+              <a:rPr sz="1000" b="1">
                 <a:solidFill>
                   <a:srgbClr val="6B3FA0"/>
                 </a:solidFill>
@@ -4918,7 +4918,7 @@
           <a:p>
             <a:pPr algn="l"/>
             <a:r>
-              <a:rPr sz="1300" b="1">
+              <a:rPr sz="1600" b="1">
                 <a:solidFill>
                   <a:srgbClr val="1A1A2E"/>
                 </a:solidFill>
@@ -4953,7 +4953,7 @@
           <a:p>
             <a:pPr algn="l"/>
             <a:r>
-              <a:rPr sz="1000" b="0">
+              <a:rPr sz="1200" b="0">
                 <a:solidFill>
                   <a:srgbClr val="5A6A80"/>
                 </a:solidFill>
@@ -5033,7 +5033,7 @@
           <a:p>
             <a:pPr algn="l"/>
             <a:r>
-              <a:rPr sz="800" b="1">
+              <a:rPr sz="1000" b="1">
                 <a:solidFill>
                   <a:srgbClr val="8A96A8"/>
                 </a:solidFill>
@@ -5068,7 +5068,7 @@
           <a:p>
             <a:pPr algn="l"/>
             <a:r>
-              <a:rPr sz="1000" b="0">
+              <a:rPr sz="1200" b="0">
                 <a:solidFill>
                   <a:srgbClr val="4A5568"/>
                 </a:solidFill>

</xml_diff>